<commit_message>
Bring custom CRM into scope across document and deck (v1.5)
Custom-built CRM advisor workspace replaces the configured off-the-shelf
CRM: scope decision 4 becomes 'Own the back office', budget rebalanced
within the R500k-R750k total, no CRM licence fees in the flat R50k/month
run cost. Deck re-cut to match the document: R500k-R750k, 2-3 months,
custom CRM, flat run fee, re-quantified payback.

Co-Authored-By: Claude Fable 5 <noreply@anthropic.com>
Claude-Session: https://claude.ai/code/session_01Hh9CNNmejyc3otWU94ScRF
</commit_message>
<xml_diff>
--- a/docs/marlin-moodley/Marlin-Moodley-Proposal-Deck.pptx
+++ b/docs/marlin-moodley/Marlin-Moodley-Proposal-Deck.pptx
@@ -514,7 +514,7 @@
           <a:p>
             <a:r>
               <a:rPr lang="en-US" dirty="0"/>
-              <a:t>Open with the tagline. Frame: this is not a website project — it is moving the practice from "email and wait" to an intelligent quote platform, live in one quarter, for under R1 million.</a:t>
+              <a:t>Open with the tagline. Frame: this is not a website project — it is moving the practice from "email and wait" to an intelligent quote platform, live in 2–3 months, for R500k–R750k.</a:t>
             </a:r>
             <a:endParaRPr lang="en-US" dirty="0"/>
           </a:p>
@@ -602,7 +602,7 @@
           <a:p>
             <a:r>
               <a:rPr lang="en-US" dirty="0"/>
-              <a:t>Envelopes firmed into a fixed-scope SOW at the end of Sprint 0. Customer-initiated WhatsApp service conversations are effectively free under Meta 2025 pricing — a service-led channel is structurally cheap to run.</a:t>
+              <a:t>Envelopes firmed into a fixed-scope SOW at the end of Sprint 0. The custom CRM means no per-seat licence fees ever — the flat R50k/month covers hosting, licences, usage, support and continuous improvement, reviewed annually.</a:t>
             </a:r>
             <a:endParaRPr lang="en-US" dirty="0"/>
           </a:p>
@@ -1218,7 +1218,7 @@
           <a:p>
             <a:r>
               <a:rPr lang="en-US" dirty="0"/>
-              <a:t>The headline: under R1 million, live in a quarter, all three channels. Emphasise that Phase 2 is deliberately unpriced — the bigger platform gets scoped on measured conversion data, not projections. That protects the client from over-committing.</a:t>
+              <a:t>The headline: R500k–R750k, live in 2–3 months, all three channels, including a custom-built CRM the client owns outright. Emphasise that Phase 2 is deliberately unpriced — scoped on measured conversion data, not projections.</a:t>
             </a:r>
             <a:endParaRPr lang="en-US" dirty="0"/>
           </a:p>
@@ -2263,7 +2263,7 @@
                 <a:ea typeface="Calibri" pitchFamily="34" charset="-122"/>
                 <a:cs typeface="Calibri" pitchFamily="34" charset="-120"/>
               </a:rPr>
-              <a:t>The R1m Launch Edition — quote journeys live on web, app and WhatsApp in 12 weeks.</a:t>
+              <a:t>The Launch Edition — quote journeys live on web, app and WhatsApp in 2–3 months.</a:t>
             </a:r>
             <a:endParaRPr lang="en-US" sz="1400" dirty="0"/>
           </a:p>
@@ -2509,7 +2509,7 @@
                 <a:ea typeface="Calibri" pitchFamily="34" charset="-122"/>
                 <a:cs typeface="Calibri" pitchFamily="34" charset="-120"/>
               </a:rPr>
-              <a:t>Where the R1m goes</a:t>
+              <a:t>Where the investment goes</a:t>
             </a:r>
             <a:endParaRPr lang="en-US" sz="3200" dirty="0"/>
           </a:p>
@@ -2587,7 +2587,7 @@
                 <a:ea typeface="Calibri" pitchFamily="34" charset="-122"/>
                 <a:cs typeface="Calibri" pitchFamily="34" charset="-120"/>
               </a:rPr>
-              <a:t>R80k – R120k</a:t>
+              <a:t>R50k – R70k</a:t>
             </a:r>
             <a:endParaRPr lang="en-US" sz="1450" dirty="0"/>
           </a:p>
@@ -2688,7 +2688,7 @@
                 <a:ea typeface="Calibri" pitchFamily="34" charset="-122"/>
                 <a:cs typeface="Calibri" pitchFamily="34" charset="-120"/>
               </a:rPr>
-              <a:t>R250k – R350k</a:t>
+              <a:t>R140k – R200k</a:t>
             </a:r>
             <a:endParaRPr lang="en-US" sz="1450" dirty="0"/>
           </a:p>
@@ -2789,7 +2789,7 @@
                 <a:ea typeface="Calibri" pitchFamily="34" charset="-122"/>
                 <a:cs typeface="Calibri" pitchFamily="34" charset="-120"/>
               </a:rPr>
-              <a:t>R150k – R220k</a:t>
+              <a:t>R80k – R120k</a:t>
             </a:r>
             <a:endParaRPr lang="en-US" sz="1450" dirty="0"/>
           </a:p>
@@ -2851,7 +2851,7 @@
                 <a:ea typeface="Calibri" pitchFamily="34" charset="-122"/>
                 <a:cs typeface="Calibri" pitchFamily="34" charset="-120"/>
               </a:rPr>
-              <a:t>Quote plumbing (admin platform + automated workflow)</a:t>
+              <a:t>Quote plumbing (admin platform + automated email workflow)</a:t>
             </a:r>
             <a:endParaRPr lang="en-US" sz="1450" dirty="0"/>
           </a:p>
@@ -2890,7 +2890,7 @@
                 <a:ea typeface="Calibri" pitchFamily="34" charset="-122"/>
                 <a:cs typeface="Calibri" pitchFamily="34" charset="-120"/>
               </a:rPr>
-              <a:t>R180k – R280k</a:t>
+              <a:t>R110k – R160k</a:t>
             </a:r>
             <a:endParaRPr lang="en-US" sz="1450" dirty="0"/>
           </a:p>
@@ -2952,7 +2952,7 @@
                 <a:ea typeface="Calibri" pitchFamily="34" charset="-122"/>
                 <a:cs typeface="Calibri" pitchFamily="34" charset="-120"/>
               </a:rPr>
-              <a:t>CRM, consent, security &amp; tracking</a:t>
+              <a:t>Custom CRM, consent, security &amp; tracking</a:t>
             </a:r>
             <a:endParaRPr lang="en-US" sz="1450" dirty="0"/>
           </a:p>
@@ -2991,7 +2991,7 @@
                 <a:ea typeface="Calibri" pitchFamily="34" charset="-122"/>
                 <a:cs typeface="Calibri" pitchFamily="34" charset="-120"/>
               </a:rPr>
-              <a:t>R100k – R150k</a:t>
+              <a:t>R120k – R200k</a:t>
             </a:r>
             <a:endParaRPr lang="en-US" sz="1450" dirty="0"/>
           </a:p>
@@ -3075,7 +3075,7 @@
                 <a:ea typeface="Calibri" pitchFamily="34" charset="-122"/>
                 <a:cs typeface="Calibri" pitchFamily="34" charset="-120"/>
               </a:rPr>
-              <a:t>LAUNCH EDITION TOTAL  ·  ~12 WEEKS</a:t>
+              <a:t>LAUNCH EDITION TOTAL  ·  2–3 MONTHS</a:t>
             </a:r>
             <a:endParaRPr lang="en-US" sz="1300" dirty="0"/>
           </a:p>
@@ -3114,7 +3114,7 @@
                 <a:ea typeface="Calibri" pitchFamily="34" charset="-122"/>
                 <a:cs typeface="Calibri" pitchFamily="34" charset="-120"/>
               </a:rPr>
-              <a:t>R850k – R1m</a:t>
+              <a:t>R500k – R750k</a:t>
             </a:r>
             <a:endParaRPr lang="en-US" sz="2000" dirty="0"/>
           </a:p>
@@ -3187,7 +3187,7 @@
                 <a:ea typeface="Calibri" pitchFamily="34" charset="-122"/>
                 <a:cs typeface="Calibri" pitchFamily="34" charset="-120"/>
               </a:rPr>
-              <a:t>R15k–R35k</a:t>
+              <a:t>Included</a:t>
             </a:r>
             <a:endParaRPr lang="en-US" sz="1600" dirty="0"/>
           </a:p>
@@ -3226,7 +3226,7 @@
                 <a:ea typeface="Calibri" pitchFamily="34" charset="-122"/>
                 <a:cs typeface="Calibri" pitchFamily="34" charset="-120"/>
               </a:rPr>
-              <a:t>Cloud, licences &amp; tooling</a:t>
+              <a:t>Hosting &amp; licences (CRM owned — no fees)</a:t>
             </a:r>
             <a:endParaRPr lang="en-US" sz="1000" dirty="0"/>
           </a:p>
@@ -3299,7 +3299,7 @@
                 <a:ea typeface="Calibri" pitchFamily="34" charset="-122"/>
                 <a:cs typeface="Calibri" pitchFamily="34" charset="-120"/>
               </a:rPr>
-              <a:t>R5k–R10k</a:t>
+              <a:t>Included</a:t>
             </a:r>
             <a:endParaRPr lang="en-US" sz="1600" dirty="0"/>
           </a:p>
@@ -3411,7 +3411,7 @@
                 <a:ea typeface="Calibri" pitchFamily="34" charset="-122"/>
                 <a:cs typeface="Calibri" pitchFamily="34" charset="-120"/>
               </a:rPr>
-              <a:t>R20k–R35k</a:t>
+              <a:t>Included</a:t>
             </a:r>
             <a:endParaRPr lang="en-US" sz="1600" dirty="0"/>
           </a:p>
@@ -3450,7 +3450,7 @@
                 <a:ea typeface="Calibri" pitchFamily="34" charset="-122"/>
                 <a:cs typeface="Calibri" pitchFamily="34" charset="-120"/>
               </a:rPr>
-              <a:t>Support &amp; improvement</a:t>
+              <a:t>Support &amp; maintenance</a:t>
             </a:r>
             <a:endParaRPr lang="en-US" sz="1000" dirty="0"/>
           </a:p>
@@ -3492,7 +3492,7 @@
                 <a:ea typeface="Calibri" pitchFamily="34" charset="-122"/>
                 <a:cs typeface="Calibri" pitchFamily="34" charset="-120"/>
               </a:rPr>
-              <a:t>Run cost
+              <a:t>Flat fee
 </a:t>
             </a:r>
             <a:pPr indent="0" marL="0">
@@ -3510,7 +3510,7 @@
                 <a:ea typeface="Calibri" pitchFamily="34" charset="-122"/>
                 <a:cs typeface="Calibri" pitchFamily="34" charset="-120"/>
               </a:rPr>
-              <a:t>R40k – R80k /month</a:t>
+              <a:t>R50k /month</a:t>
             </a:r>
             <a:endParaRPr lang="en-US" sz="1300" dirty="0"/>
           </a:p>
@@ -4383,7 +4383,7 @@
                 <a:ea typeface="Calibri" pitchFamily="34" charset="-122"/>
                 <a:cs typeface="Calibri" pitchFamily="34" charset="-120"/>
               </a:rPr>
-              <a:t>an additional R400k–R800k in annual recurring commission within 18 months recovers the R1m in roughly 18–30 months — while building a systematised, sellable book.</a:t>
+              <a:t>an additional R300k–R500k in annual recurring commission within 18 months recovers the investment in roughly 15–24 months — while building a systematised, sellable book.</a:t>
             </a:r>
             <a:endParaRPr lang="en-US" sz="1350" dirty="0"/>
           </a:p>
@@ -5273,7 +5273,7 @@
                 <a:ea typeface="Calibri" pitchFamily="34" charset="-122"/>
                 <a:cs typeface="Calibri" pitchFamily="34" charset="-120"/>
               </a:rPr>
-              <a:t>R80k–R120k, 2 weeks: vendors, POPIA, fixed-scope build plan</a:t>
+              <a:t>R50k–R70k, 2 weeks: vendors, POPIA, fixed-scope build plan</a:t>
             </a:r>
             <a:endParaRPr lang="en-US" sz="1200" dirty="0"/>
           </a:p>
@@ -8415,23 +8415,23 @@
         <p:spPr>
           <a:xfrm>
             <a:off x="1005840" y="2148840"/>
-            <a:ext cx="2926080" cy="594360"/>
-          </a:xfrm>
-          <a:prstGeom prst="rect">
-            <a:avLst/>
-          </a:prstGeom>
-          <a:noFill/>
-          <a:ln/>
-        </p:spPr>
-        <p:txBody>
-          <a:bodyPr wrap="square" lIns="0" tIns="0" rIns="0" bIns="0" rtlCol="0" anchor="ctr"/>
-          <a:lstStyle/>
-          <a:p>
-            <a:pPr indent="0" marL="0">
-              <a:buNone/>
-            </a:pPr>
-            <a:r>
-              <a:rPr lang="en-US" sz="3000" b="1" dirty="0">
+            <a:ext cx="3017520" cy="594360"/>
+          </a:xfrm>
+          <a:prstGeom prst="rect">
+            <a:avLst/>
+          </a:prstGeom>
+          <a:noFill/>
+          <a:ln/>
+        </p:spPr>
+        <p:txBody>
+          <a:bodyPr wrap="square" lIns="0" tIns="0" rIns="0" bIns="0" rtlCol="0" anchor="ctr"/>
+          <a:lstStyle/>
+          <a:p>
+            <a:pPr indent="0" marL="0">
+              <a:buNone/>
+            </a:pPr>
+            <a:r>
+              <a:rPr lang="en-US" sz="2700" b="1" dirty="0">
                 <a:solidFill>
                   <a:srgbClr val="FFFFFF"/>
                 </a:solidFill>
@@ -8439,9 +8439,9 @@
                 <a:ea typeface="Calibri" pitchFamily="34" charset="-122"/>
                 <a:cs typeface="Calibri" pitchFamily="34" charset="-120"/>
               </a:rPr>
-              <a:t>R850k – R1m</a:t>
-            </a:r>
-            <a:endParaRPr lang="en-US" sz="3000" dirty="0"/>
+              <a:t>R500k–R750k</a:t>
+            </a:r>
+            <a:endParaRPr lang="en-US" sz="2700" dirty="0"/>
           </a:p>
         </p:txBody>
       </p:sp>
@@ -8522,23 +8522,23 @@
         <p:spPr>
           <a:xfrm>
             <a:off x="4754880" y="2148840"/>
-            <a:ext cx="2926080" cy="594360"/>
-          </a:xfrm>
-          <a:prstGeom prst="rect">
-            <a:avLst/>
-          </a:prstGeom>
-          <a:noFill/>
-          <a:ln/>
-        </p:spPr>
-        <p:txBody>
-          <a:bodyPr wrap="square" lIns="0" tIns="0" rIns="0" bIns="0" rtlCol="0" anchor="ctr"/>
-          <a:lstStyle/>
-          <a:p>
-            <a:pPr indent="0" marL="0">
-              <a:buNone/>
-            </a:pPr>
-            <a:r>
-              <a:rPr lang="en-US" sz="3000" b="1" dirty="0">
+            <a:ext cx="3017520" cy="594360"/>
+          </a:xfrm>
+          <a:prstGeom prst="rect">
+            <a:avLst/>
+          </a:prstGeom>
+          <a:noFill/>
+          <a:ln/>
+        </p:spPr>
+        <p:txBody>
+          <a:bodyPr wrap="square" lIns="0" tIns="0" rIns="0" bIns="0" rtlCol="0" anchor="ctr"/>
+          <a:lstStyle/>
+          <a:p>
+            <a:pPr indent="0" marL="0">
+              <a:buNone/>
+            </a:pPr>
+            <a:r>
+              <a:rPr lang="en-US" sz="2700" b="1" dirty="0">
                 <a:solidFill>
                   <a:srgbClr val="FFFFFF"/>
                 </a:solidFill>
@@ -8546,9 +8546,9 @@
                 <a:ea typeface="Calibri" pitchFamily="34" charset="-122"/>
                 <a:cs typeface="Calibri" pitchFamily="34" charset="-120"/>
               </a:rPr>
-              <a:t>12 weeks</a:t>
-            </a:r>
-            <a:endParaRPr lang="en-US" sz="3000" dirty="0"/>
+              <a:t>2–3 months</a:t>
+            </a:r>
+            <a:endParaRPr lang="en-US" sz="2700" dirty="0"/>
           </a:p>
         </p:txBody>
       </p:sp>
@@ -8629,23 +8629,23 @@
         <p:spPr>
           <a:xfrm>
             <a:off x="8503920" y="2148840"/>
-            <a:ext cx="2926080" cy="594360"/>
-          </a:xfrm>
-          <a:prstGeom prst="rect">
-            <a:avLst/>
-          </a:prstGeom>
-          <a:noFill/>
-          <a:ln/>
-        </p:spPr>
-        <p:txBody>
-          <a:bodyPr wrap="square" lIns="0" tIns="0" rIns="0" bIns="0" rtlCol="0" anchor="ctr"/>
-          <a:lstStyle/>
-          <a:p>
-            <a:pPr indent="0" marL="0">
-              <a:buNone/>
-            </a:pPr>
-            <a:r>
-              <a:rPr lang="en-US" sz="3000" b="1" dirty="0">
+            <a:ext cx="3017520" cy="594360"/>
+          </a:xfrm>
+          <a:prstGeom prst="rect">
+            <a:avLst/>
+          </a:prstGeom>
+          <a:noFill/>
+          <a:ln/>
+        </p:spPr>
+        <p:txBody>
+          <a:bodyPr wrap="square" lIns="0" tIns="0" rIns="0" bIns="0" rtlCol="0" anchor="ctr"/>
+          <a:lstStyle/>
+          <a:p>
+            <a:pPr indent="0" marL="0">
+              <a:buNone/>
+            </a:pPr>
+            <a:r>
+              <a:rPr lang="en-US" sz="2700" b="1" dirty="0">
                 <a:solidFill>
                   <a:srgbClr val="FFFFFF"/>
                 </a:solidFill>
@@ -8655,7 +8655,7 @@
               </a:rPr>
               <a:t>3 channels</a:t>
             </a:r>
-            <a:endParaRPr lang="en-US" sz="3000" dirty="0"/>
+            <a:endParaRPr lang="en-US" sz="2700" dirty="0"/>
           </a:p>
         </p:txBody>
       </p:sp>
@@ -8786,7 +8786,7 @@
                 <a:ea typeface="Calibri" pitchFamily="34" charset="-122"/>
                 <a:cs typeface="Calibri" pitchFamily="34" charset="-120"/>
               </a:rPr>
-              <a:t>CRM advisor workspace with document vault, consent and full FAIS record-keeping</a:t>
+              <a:t>Custom-built CRM advisor workspace — owned, licence-free, with document vault and full FAIS record-keeping</a:t>
             </a:r>
             <a:endParaRPr lang="en-US" sz="1500" dirty="0"/>
           </a:p>
@@ -8810,7 +8810,7 @@
                 <a:ea typeface="Calibri" pitchFamily="34" charset="-122"/>
                 <a:cs typeface="Calibri" pitchFamily="34" charset="-120"/>
               </a:rPr>
-              <a:t>Run cost from launch: R40k–R80k per month</a:t>
+              <a:t>Flat R50k per month for hosting, support &amp; maintenance from launch</a:t>
             </a:r>
             <a:endParaRPr lang="en-US" sz="1500" dirty="0"/>
           </a:p>
@@ -8849,7 +8849,7 @@
                 <a:ea typeface="Calibri" pitchFamily="34" charset="-122"/>
                 <a:cs typeface="Calibri" pitchFamily="34" charset="-120"/>
               </a:rPr>
-              <a:t>Phase 2 — native app, AI agent suite, custom Customer 360, predictive analytics — is scoped and priced on real launch data.</a:t>
+              <a:t>Phase 2 — native app, AI agent suite, Customer 360 intelligence, predictive analytics — is scoped and priced on real launch data.</a:t>
             </a:r>
             <a:endParaRPr lang="en-US" sz="1300" dirty="0"/>
           </a:p>
@@ -9546,7 +9546,7 @@
                 <a:ea typeface="Calibri" pitchFamily="34" charset="-122"/>
                 <a:cs typeface="Calibri" pitchFamily="34" charset="-120"/>
               </a:rPr>
-              <a:t>4 · Configure the back office</a:t>
+              <a:t>4 · Own the back office</a:t>
             </a:r>
             <a:endParaRPr lang="en-US" sz="1600" dirty="0"/>
           </a:p>
@@ -9588,7 +9588,7 @@
                 <a:ea typeface="Calibri" pitchFamily="34" charset="-122"/>
                 <a:cs typeface="Calibri" pitchFamily="34" charset="-120"/>
               </a:rPr>
-              <a:t>An off-the-shelf CRM is the advisor workspace — pipeline, cases, WhatsApp inbox on the client record — with documents in an encrypted cloud vault surfaced through it.</a:t>
+              <a:t>A custom-built CRM is the advisor workspace — pipeline, cases, WhatsApp inbox threaded per client, encrypted document vault. No licence fees, one data model, reusable IP.</a:t>
             </a:r>
             <a:endParaRPr lang="en-US" sz="1150" dirty="0"/>
           </a:p>
@@ -11573,7 +11573,7 @@
                 <a:ea typeface="Calibri" pitchFamily="34" charset="-122"/>
                 <a:cs typeface="Calibri" pitchFamily="34" charset="-120"/>
               </a:rPr>
-              <a:t>12 weeks to live</a:t>
+              <a:t>2–3 months to live</a:t>
             </a:r>
             <a:endParaRPr lang="en-US" sz="3200" dirty="0"/>
           </a:p>
@@ -11825,7 +11825,7 @@
                 <a:ea typeface="Calibri" pitchFamily="34" charset="-122"/>
                 <a:cs typeface="Calibri" pitchFamily="34" charset="-120"/>
               </a:rPr>
-              <a:t>WEEKS 3–10</a:t>
+              <a:t>WEEKS 3–9</a:t>
             </a:r>
             <a:endParaRPr lang="en-US" sz="1100" dirty="0"/>
           </a:p>
@@ -11906,7 +11906,7 @@
                 <a:ea typeface="Calibri" pitchFamily="34" charset="-122"/>
                 <a:cs typeface="Calibri" pitchFamily="34" charset="-120"/>
               </a:rPr>
-              <a:t>Web/PWA quote journey · WhatsApp journeys with document upload · admin-platform integration + automated life workflow · CRM &amp; document vault · hardening</a:t>
+              <a:t>Web/PWA quote journey · WhatsApp journeys with document upload · admin-platform integration + automated life workflow · custom CRM &amp; document vault · hardening</a:t>
             </a:r>
             <a:endParaRPr lang="en-US" sz="1150" dirty="0"/>
           </a:p>
@@ -11945,7 +11945,7 @@
                 <a:ea typeface="Calibri" pitchFamily="34" charset="-122"/>
                 <a:cs typeface="Calibri" pitchFamily="34" charset="-120"/>
               </a:rPr>
-              <a:t>WEEKS 11–12</a:t>
+              <a:t>WEEKS 10–12</a:t>
             </a:r>
             <a:endParaRPr lang="en-US" sz="1100" dirty="0"/>
           </a:p>

</xml_diff>

<commit_message>
Update Marlin Moodley proposal to v1.5 with discovery questionnaire (#8)
R500k-R750k Launch Edition with custom CRM in scope, 2-3 months, flat R50k/month; deck re-cut to match; adds the two-page client discovery questionnaire.
</commit_message>
<xml_diff>
--- a/docs/marlin-moodley/Marlin-Moodley-Proposal-Deck.pptx
+++ b/docs/marlin-moodley/Marlin-Moodley-Proposal-Deck.pptx
@@ -514,7 +514,7 @@
           <a:p>
             <a:r>
               <a:rPr lang="en-US" dirty="0"/>
-              <a:t>Open with the tagline. Frame: this is not a website project — it is moving the practice from "email and wait" to an intelligent quote platform, live in one quarter, for under R1 million.</a:t>
+              <a:t>Open with the tagline. Frame: this is not a website project — it is moving the practice from "email and wait" to an intelligent quote platform, live in 2–3 months, for R500k–R750k.</a:t>
             </a:r>
             <a:endParaRPr lang="en-US" dirty="0"/>
           </a:p>
@@ -602,7 +602,7 @@
           <a:p>
             <a:r>
               <a:rPr lang="en-US" dirty="0"/>
-              <a:t>Envelopes firmed into a fixed-scope SOW at the end of Sprint 0. Customer-initiated WhatsApp service conversations are effectively free under Meta 2025 pricing — a service-led channel is structurally cheap to run.</a:t>
+              <a:t>Envelopes firmed into a fixed-scope SOW at the end of Sprint 0. The custom CRM means no per-seat licence fees ever — the flat R50k/month covers hosting, licences, usage, support and continuous improvement, reviewed annually.</a:t>
             </a:r>
             <a:endParaRPr lang="en-US" dirty="0"/>
           </a:p>
@@ -1218,7 +1218,7 @@
           <a:p>
             <a:r>
               <a:rPr lang="en-US" dirty="0"/>
-              <a:t>The headline: under R1 million, live in a quarter, all three channels. Emphasise that Phase 2 is deliberately unpriced — the bigger platform gets scoped on measured conversion data, not projections. That protects the client from over-committing.</a:t>
+              <a:t>The headline: R500k–R750k, live in 2–3 months, all three channels, including a custom-built CRM the client owns outright. Emphasise that Phase 2 is deliberately unpriced — scoped on measured conversion data, not projections.</a:t>
             </a:r>
             <a:endParaRPr lang="en-US" dirty="0"/>
           </a:p>
@@ -2263,7 +2263,7 @@
                 <a:ea typeface="Calibri" pitchFamily="34" charset="-122"/>
                 <a:cs typeface="Calibri" pitchFamily="34" charset="-120"/>
               </a:rPr>
-              <a:t>The R1m Launch Edition — quote journeys live on web, app and WhatsApp in 12 weeks.</a:t>
+              <a:t>The Launch Edition — quote journeys live on web, app and WhatsApp in 2–3 months.</a:t>
             </a:r>
             <a:endParaRPr lang="en-US" sz="1400" dirty="0"/>
           </a:p>
@@ -2509,7 +2509,7 @@
                 <a:ea typeface="Calibri" pitchFamily="34" charset="-122"/>
                 <a:cs typeface="Calibri" pitchFamily="34" charset="-120"/>
               </a:rPr>
-              <a:t>Where the R1m goes</a:t>
+              <a:t>Where the investment goes</a:t>
             </a:r>
             <a:endParaRPr lang="en-US" sz="3200" dirty="0"/>
           </a:p>
@@ -2587,7 +2587,7 @@
                 <a:ea typeface="Calibri" pitchFamily="34" charset="-122"/>
                 <a:cs typeface="Calibri" pitchFamily="34" charset="-120"/>
               </a:rPr>
-              <a:t>R80k – R120k</a:t>
+              <a:t>R50k – R70k</a:t>
             </a:r>
             <a:endParaRPr lang="en-US" sz="1450" dirty="0"/>
           </a:p>
@@ -2688,7 +2688,7 @@
                 <a:ea typeface="Calibri" pitchFamily="34" charset="-122"/>
                 <a:cs typeface="Calibri" pitchFamily="34" charset="-120"/>
               </a:rPr>
-              <a:t>R250k – R350k</a:t>
+              <a:t>R140k – R200k</a:t>
             </a:r>
             <a:endParaRPr lang="en-US" sz="1450" dirty="0"/>
           </a:p>
@@ -2789,7 +2789,7 @@
                 <a:ea typeface="Calibri" pitchFamily="34" charset="-122"/>
                 <a:cs typeface="Calibri" pitchFamily="34" charset="-120"/>
               </a:rPr>
-              <a:t>R150k – R220k</a:t>
+              <a:t>R80k – R120k</a:t>
             </a:r>
             <a:endParaRPr lang="en-US" sz="1450" dirty="0"/>
           </a:p>
@@ -2851,7 +2851,7 @@
                 <a:ea typeface="Calibri" pitchFamily="34" charset="-122"/>
                 <a:cs typeface="Calibri" pitchFamily="34" charset="-120"/>
               </a:rPr>
-              <a:t>Quote plumbing (admin platform + automated workflow)</a:t>
+              <a:t>Quote plumbing (admin platform + automated email workflow)</a:t>
             </a:r>
             <a:endParaRPr lang="en-US" sz="1450" dirty="0"/>
           </a:p>
@@ -2890,7 +2890,7 @@
                 <a:ea typeface="Calibri" pitchFamily="34" charset="-122"/>
                 <a:cs typeface="Calibri" pitchFamily="34" charset="-120"/>
               </a:rPr>
-              <a:t>R180k – R280k</a:t>
+              <a:t>R110k – R160k</a:t>
             </a:r>
             <a:endParaRPr lang="en-US" sz="1450" dirty="0"/>
           </a:p>
@@ -2952,7 +2952,7 @@
                 <a:ea typeface="Calibri" pitchFamily="34" charset="-122"/>
                 <a:cs typeface="Calibri" pitchFamily="34" charset="-120"/>
               </a:rPr>
-              <a:t>CRM, consent, security &amp; tracking</a:t>
+              <a:t>Custom CRM, consent, security &amp; tracking</a:t>
             </a:r>
             <a:endParaRPr lang="en-US" sz="1450" dirty="0"/>
           </a:p>
@@ -2991,7 +2991,7 @@
                 <a:ea typeface="Calibri" pitchFamily="34" charset="-122"/>
                 <a:cs typeface="Calibri" pitchFamily="34" charset="-120"/>
               </a:rPr>
-              <a:t>R100k – R150k</a:t>
+              <a:t>R120k – R200k</a:t>
             </a:r>
             <a:endParaRPr lang="en-US" sz="1450" dirty="0"/>
           </a:p>
@@ -3075,7 +3075,7 @@
                 <a:ea typeface="Calibri" pitchFamily="34" charset="-122"/>
                 <a:cs typeface="Calibri" pitchFamily="34" charset="-120"/>
               </a:rPr>
-              <a:t>LAUNCH EDITION TOTAL  ·  ~12 WEEKS</a:t>
+              <a:t>LAUNCH EDITION TOTAL  ·  2–3 MONTHS</a:t>
             </a:r>
             <a:endParaRPr lang="en-US" sz="1300" dirty="0"/>
           </a:p>
@@ -3114,7 +3114,7 @@
                 <a:ea typeface="Calibri" pitchFamily="34" charset="-122"/>
                 <a:cs typeface="Calibri" pitchFamily="34" charset="-120"/>
               </a:rPr>
-              <a:t>R850k – R1m</a:t>
+              <a:t>R500k – R750k</a:t>
             </a:r>
             <a:endParaRPr lang="en-US" sz="2000" dirty="0"/>
           </a:p>
@@ -3187,7 +3187,7 @@
                 <a:ea typeface="Calibri" pitchFamily="34" charset="-122"/>
                 <a:cs typeface="Calibri" pitchFamily="34" charset="-120"/>
               </a:rPr>
-              <a:t>R15k–R35k</a:t>
+              <a:t>Included</a:t>
             </a:r>
             <a:endParaRPr lang="en-US" sz="1600" dirty="0"/>
           </a:p>
@@ -3226,7 +3226,7 @@
                 <a:ea typeface="Calibri" pitchFamily="34" charset="-122"/>
                 <a:cs typeface="Calibri" pitchFamily="34" charset="-120"/>
               </a:rPr>
-              <a:t>Cloud, licences &amp; tooling</a:t>
+              <a:t>Hosting &amp; licences (CRM owned — no fees)</a:t>
             </a:r>
             <a:endParaRPr lang="en-US" sz="1000" dirty="0"/>
           </a:p>
@@ -3299,7 +3299,7 @@
                 <a:ea typeface="Calibri" pitchFamily="34" charset="-122"/>
                 <a:cs typeface="Calibri" pitchFamily="34" charset="-120"/>
               </a:rPr>
-              <a:t>R5k–R10k</a:t>
+              <a:t>Included</a:t>
             </a:r>
             <a:endParaRPr lang="en-US" sz="1600" dirty="0"/>
           </a:p>
@@ -3411,7 +3411,7 @@
                 <a:ea typeface="Calibri" pitchFamily="34" charset="-122"/>
                 <a:cs typeface="Calibri" pitchFamily="34" charset="-120"/>
               </a:rPr>
-              <a:t>R20k–R35k</a:t>
+              <a:t>Included</a:t>
             </a:r>
             <a:endParaRPr lang="en-US" sz="1600" dirty="0"/>
           </a:p>
@@ -3450,7 +3450,7 @@
                 <a:ea typeface="Calibri" pitchFamily="34" charset="-122"/>
                 <a:cs typeface="Calibri" pitchFamily="34" charset="-120"/>
               </a:rPr>
-              <a:t>Support &amp; improvement</a:t>
+              <a:t>Support &amp; maintenance</a:t>
             </a:r>
             <a:endParaRPr lang="en-US" sz="1000" dirty="0"/>
           </a:p>
@@ -3492,7 +3492,7 @@
                 <a:ea typeface="Calibri" pitchFamily="34" charset="-122"/>
                 <a:cs typeface="Calibri" pitchFamily="34" charset="-120"/>
               </a:rPr>
-              <a:t>Run cost
+              <a:t>Flat fee
 </a:t>
             </a:r>
             <a:pPr indent="0" marL="0">
@@ -3510,7 +3510,7 @@
                 <a:ea typeface="Calibri" pitchFamily="34" charset="-122"/>
                 <a:cs typeface="Calibri" pitchFamily="34" charset="-120"/>
               </a:rPr>
-              <a:t>R40k – R80k /month</a:t>
+              <a:t>R50k /month</a:t>
             </a:r>
             <a:endParaRPr lang="en-US" sz="1300" dirty="0"/>
           </a:p>
@@ -4383,7 +4383,7 @@
                 <a:ea typeface="Calibri" pitchFamily="34" charset="-122"/>
                 <a:cs typeface="Calibri" pitchFamily="34" charset="-120"/>
               </a:rPr>
-              <a:t>an additional R400k–R800k in annual recurring commission within 18 months recovers the R1m in roughly 18–30 months — while building a systematised, sellable book.</a:t>
+              <a:t>an additional R300k–R500k in annual recurring commission within 18 months recovers the investment in roughly 15–24 months — while building a systematised, sellable book.</a:t>
             </a:r>
             <a:endParaRPr lang="en-US" sz="1350" dirty="0"/>
           </a:p>
@@ -5273,7 +5273,7 @@
                 <a:ea typeface="Calibri" pitchFamily="34" charset="-122"/>
                 <a:cs typeface="Calibri" pitchFamily="34" charset="-120"/>
               </a:rPr>
-              <a:t>R80k–R120k, 2 weeks: vendors, POPIA, fixed-scope build plan</a:t>
+              <a:t>R50k–R70k, 2 weeks: vendors, POPIA, fixed-scope build plan</a:t>
             </a:r>
             <a:endParaRPr lang="en-US" sz="1200" dirty="0"/>
           </a:p>
@@ -8415,23 +8415,23 @@
         <p:spPr>
           <a:xfrm>
             <a:off x="1005840" y="2148840"/>
-            <a:ext cx="2926080" cy="594360"/>
-          </a:xfrm>
-          <a:prstGeom prst="rect">
-            <a:avLst/>
-          </a:prstGeom>
-          <a:noFill/>
-          <a:ln/>
-        </p:spPr>
-        <p:txBody>
-          <a:bodyPr wrap="square" lIns="0" tIns="0" rIns="0" bIns="0" rtlCol="0" anchor="ctr"/>
-          <a:lstStyle/>
-          <a:p>
-            <a:pPr indent="0" marL="0">
-              <a:buNone/>
-            </a:pPr>
-            <a:r>
-              <a:rPr lang="en-US" sz="3000" b="1" dirty="0">
+            <a:ext cx="3017520" cy="594360"/>
+          </a:xfrm>
+          <a:prstGeom prst="rect">
+            <a:avLst/>
+          </a:prstGeom>
+          <a:noFill/>
+          <a:ln/>
+        </p:spPr>
+        <p:txBody>
+          <a:bodyPr wrap="square" lIns="0" tIns="0" rIns="0" bIns="0" rtlCol="0" anchor="ctr"/>
+          <a:lstStyle/>
+          <a:p>
+            <a:pPr indent="0" marL="0">
+              <a:buNone/>
+            </a:pPr>
+            <a:r>
+              <a:rPr lang="en-US" sz="2700" b="1" dirty="0">
                 <a:solidFill>
                   <a:srgbClr val="FFFFFF"/>
                 </a:solidFill>
@@ -8439,9 +8439,9 @@
                 <a:ea typeface="Calibri" pitchFamily="34" charset="-122"/>
                 <a:cs typeface="Calibri" pitchFamily="34" charset="-120"/>
               </a:rPr>
-              <a:t>R850k – R1m</a:t>
-            </a:r>
-            <a:endParaRPr lang="en-US" sz="3000" dirty="0"/>
+              <a:t>R500k–R750k</a:t>
+            </a:r>
+            <a:endParaRPr lang="en-US" sz="2700" dirty="0"/>
           </a:p>
         </p:txBody>
       </p:sp>
@@ -8522,23 +8522,23 @@
         <p:spPr>
           <a:xfrm>
             <a:off x="4754880" y="2148840"/>
-            <a:ext cx="2926080" cy="594360"/>
-          </a:xfrm>
-          <a:prstGeom prst="rect">
-            <a:avLst/>
-          </a:prstGeom>
-          <a:noFill/>
-          <a:ln/>
-        </p:spPr>
-        <p:txBody>
-          <a:bodyPr wrap="square" lIns="0" tIns="0" rIns="0" bIns="0" rtlCol="0" anchor="ctr"/>
-          <a:lstStyle/>
-          <a:p>
-            <a:pPr indent="0" marL="0">
-              <a:buNone/>
-            </a:pPr>
-            <a:r>
-              <a:rPr lang="en-US" sz="3000" b="1" dirty="0">
+            <a:ext cx="3017520" cy="594360"/>
+          </a:xfrm>
+          <a:prstGeom prst="rect">
+            <a:avLst/>
+          </a:prstGeom>
+          <a:noFill/>
+          <a:ln/>
+        </p:spPr>
+        <p:txBody>
+          <a:bodyPr wrap="square" lIns="0" tIns="0" rIns="0" bIns="0" rtlCol="0" anchor="ctr"/>
+          <a:lstStyle/>
+          <a:p>
+            <a:pPr indent="0" marL="0">
+              <a:buNone/>
+            </a:pPr>
+            <a:r>
+              <a:rPr lang="en-US" sz="2700" b="1" dirty="0">
                 <a:solidFill>
                   <a:srgbClr val="FFFFFF"/>
                 </a:solidFill>
@@ -8546,9 +8546,9 @@
                 <a:ea typeface="Calibri" pitchFamily="34" charset="-122"/>
                 <a:cs typeface="Calibri" pitchFamily="34" charset="-120"/>
               </a:rPr>
-              <a:t>12 weeks</a:t>
-            </a:r>
-            <a:endParaRPr lang="en-US" sz="3000" dirty="0"/>
+              <a:t>2–3 months</a:t>
+            </a:r>
+            <a:endParaRPr lang="en-US" sz="2700" dirty="0"/>
           </a:p>
         </p:txBody>
       </p:sp>
@@ -8629,23 +8629,23 @@
         <p:spPr>
           <a:xfrm>
             <a:off x="8503920" y="2148840"/>
-            <a:ext cx="2926080" cy="594360"/>
-          </a:xfrm>
-          <a:prstGeom prst="rect">
-            <a:avLst/>
-          </a:prstGeom>
-          <a:noFill/>
-          <a:ln/>
-        </p:spPr>
-        <p:txBody>
-          <a:bodyPr wrap="square" lIns="0" tIns="0" rIns="0" bIns="0" rtlCol="0" anchor="ctr"/>
-          <a:lstStyle/>
-          <a:p>
-            <a:pPr indent="0" marL="0">
-              <a:buNone/>
-            </a:pPr>
-            <a:r>
-              <a:rPr lang="en-US" sz="3000" b="1" dirty="0">
+            <a:ext cx="3017520" cy="594360"/>
+          </a:xfrm>
+          <a:prstGeom prst="rect">
+            <a:avLst/>
+          </a:prstGeom>
+          <a:noFill/>
+          <a:ln/>
+        </p:spPr>
+        <p:txBody>
+          <a:bodyPr wrap="square" lIns="0" tIns="0" rIns="0" bIns="0" rtlCol="0" anchor="ctr"/>
+          <a:lstStyle/>
+          <a:p>
+            <a:pPr indent="0" marL="0">
+              <a:buNone/>
+            </a:pPr>
+            <a:r>
+              <a:rPr lang="en-US" sz="2700" b="1" dirty="0">
                 <a:solidFill>
                   <a:srgbClr val="FFFFFF"/>
                 </a:solidFill>
@@ -8655,7 +8655,7 @@
               </a:rPr>
               <a:t>3 channels</a:t>
             </a:r>
-            <a:endParaRPr lang="en-US" sz="3000" dirty="0"/>
+            <a:endParaRPr lang="en-US" sz="2700" dirty="0"/>
           </a:p>
         </p:txBody>
       </p:sp>
@@ -8786,7 +8786,7 @@
                 <a:ea typeface="Calibri" pitchFamily="34" charset="-122"/>
                 <a:cs typeface="Calibri" pitchFamily="34" charset="-120"/>
               </a:rPr>
-              <a:t>CRM advisor workspace with document vault, consent and full FAIS record-keeping</a:t>
+              <a:t>Custom-built CRM advisor workspace — owned, licence-free, with document vault and full FAIS record-keeping</a:t>
             </a:r>
             <a:endParaRPr lang="en-US" sz="1500" dirty="0"/>
           </a:p>
@@ -8810,7 +8810,7 @@
                 <a:ea typeface="Calibri" pitchFamily="34" charset="-122"/>
                 <a:cs typeface="Calibri" pitchFamily="34" charset="-120"/>
               </a:rPr>
-              <a:t>Run cost from launch: R40k–R80k per month</a:t>
+              <a:t>Flat R50k per month for hosting, support &amp; maintenance from launch</a:t>
             </a:r>
             <a:endParaRPr lang="en-US" sz="1500" dirty="0"/>
           </a:p>
@@ -8849,7 +8849,7 @@
                 <a:ea typeface="Calibri" pitchFamily="34" charset="-122"/>
                 <a:cs typeface="Calibri" pitchFamily="34" charset="-120"/>
               </a:rPr>
-              <a:t>Phase 2 — native app, AI agent suite, custom Customer 360, predictive analytics — is scoped and priced on real launch data.</a:t>
+              <a:t>Phase 2 — native app, AI agent suite, Customer 360 intelligence, predictive analytics — is scoped and priced on real launch data.</a:t>
             </a:r>
             <a:endParaRPr lang="en-US" sz="1300" dirty="0"/>
           </a:p>
@@ -9546,7 +9546,7 @@
                 <a:ea typeface="Calibri" pitchFamily="34" charset="-122"/>
                 <a:cs typeface="Calibri" pitchFamily="34" charset="-120"/>
               </a:rPr>
-              <a:t>4 · Configure the back office</a:t>
+              <a:t>4 · Own the back office</a:t>
             </a:r>
             <a:endParaRPr lang="en-US" sz="1600" dirty="0"/>
           </a:p>
@@ -9588,7 +9588,7 @@
                 <a:ea typeface="Calibri" pitchFamily="34" charset="-122"/>
                 <a:cs typeface="Calibri" pitchFamily="34" charset="-120"/>
               </a:rPr>
-              <a:t>An off-the-shelf CRM is the advisor workspace — pipeline, cases, WhatsApp inbox on the client record — with documents in an encrypted cloud vault surfaced through it.</a:t>
+              <a:t>A custom-built CRM is the advisor workspace — pipeline, cases, WhatsApp inbox threaded per client, encrypted document vault. No licence fees, one data model, reusable IP.</a:t>
             </a:r>
             <a:endParaRPr lang="en-US" sz="1150" dirty="0"/>
           </a:p>
@@ -11573,7 +11573,7 @@
                 <a:ea typeface="Calibri" pitchFamily="34" charset="-122"/>
                 <a:cs typeface="Calibri" pitchFamily="34" charset="-120"/>
               </a:rPr>
-              <a:t>12 weeks to live</a:t>
+              <a:t>2–3 months to live</a:t>
             </a:r>
             <a:endParaRPr lang="en-US" sz="3200" dirty="0"/>
           </a:p>
@@ -11825,7 +11825,7 @@
                 <a:ea typeface="Calibri" pitchFamily="34" charset="-122"/>
                 <a:cs typeface="Calibri" pitchFamily="34" charset="-120"/>
               </a:rPr>
-              <a:t>WEEKS 3–10</a:t>
+              <a:t>WEEKS 3–9</a:t>
             </a:r>
             <a:endParaRPr lang="en-US" sz="1100" dirty="0"/>
           </a:p>
@@ -11906,7 +11906,7 @@
                 <a:ea typeface="Calibri" pitchFamily="34" charset="-122"/>
                 <a:cs typeface="Calibri" pitchFamily="34" charset="-120"/>
               </a:rPr>
-              <a:t>Web/PWA quote journey · WhatsApp journeys with document upload · admin-platform integration + automated life workflow · CRM &amp; document vault · hardening</a:t>
+              <a:t>Web/PWA quote journey · WhatsApp journeys with document upload · admin-platform integration + automated life workflow · custom CRM &amp; document vault · hardening</a:t>
             </a:r>
             <a:endParaRPr lang="en-US" sz="1150" dirty="0"/>
           </a:p>
@@ -11945,7 +11945,7 @@
                 <a:ea typeface="Calibri" pitchFamily="34" charset="-122"/>
                 <a:cs typeface="Calibri" pitchFamily="34" charset="-120"/>
               </a:rPr>
-              <a:t>WEEKS 11–12</a:t>
+              <a:t>WEEKS 10–12</a:t>
             </a:r>
             <a:endParaRPr lang="en-US" sz="1100" dirty="0"/>
           </a:p>

</xml_diff>